<commit_message>
fix: 브랜드 영문 표기 정정 (NOOER→nooer, TODDLZ→Toddles)
배송/설치가이드와 동일 룰 적용:
- 누어 = nooer (반드시 소문자)
- 토들즈 = Toddles (첫 글자만 대문자)
- 슬립퍼 = SLEEPER (현재 모두 대문자, 변경 없음)

수정: build_deck_v2.js (소스) → split_and_build.js → 두 세션 PPT → PNG → HTML 전 라인 자동 전파

Co-Authored-By: Claude Opus 4.7 (1M context) <noreply@anthropic.com>
</commit_message>
<xml_diff>
--- a/assets/download/오가렌_세일즈가이드_세션2.pptx
+++ b/assets/download/오가렌_세일즈가이드_세션2.pptx
@@ -4360,7 +4360,7 @@
                 <a:ea typeface="Malgun Gothic" pitchFamily="34" charset="-122"/>
                 <a:cs typeface="Malgun Gothic" pitchFamily="34" charset="-120"/>
               </a:rPr>
-              <a:t>SLEEPER  ·  NOOER  ·  TODDLZ</a:t>
+              <a:t>SLEEPER  ·  nooer  ·  Toddles</a:t>
             </a:r>
             <a:endParaRPr lang="en-US" sz="1300" dirty="0"/>
           </a:p>
@@ -5365,7 +5365,7 @@
                 <a:ea typeface="Malgun Gothic" pitchFamily="34" charset="-122"/>
                 <a:cs typeface="Malgun Gothic" pitchFamily="34" charset="-120"/>
               </a:rPr>
-              <a:t>OGAREN  ·  SLEEPER  ·  NOOER  ·  TODDLZ</a:t>
+              <a:t>OGAREN  ·  SLEEPER  ·  nooer  ·  Toddles</a:t>
             </a:r>
             <a:endParaRPr lang="en-US" sz="800" dirty="0"/>
           </a:p>
@@ -6760,7 +6760,7 @@
                 <a:ea typeface="Malgun Gothic" pitchFamily="34" charset="-122"/>
                 <a:cs typeface="Malgun Gothic" pitchFamily="34" charset="-120"/>
               </a:rPr>
-              <a:t>OGAREN  ·  SLEEPER  ·  NOOER  ·  TODDLZ</a:t>
+              <a:t>OGAREN  ·  SLEEPER  ·  nooer  ·  Toddles</a:t>
             </a:r>
             <a:endParaRPr lang="en-US" sz="800" dirty="0"/>
           </a:p>
@@ -7437,7 +7437,7 @@
                 <a:ea typeface="Malgun Gothic" pitchFamily="34" charset="-122"/>
                 <a:cs typeface="Malgun Gothic" pitchFamily="34" charset="-120"/>
               </a:rPr>
-              <a:t>OGAREN  ·  SLEEPER  ·  NOOER  ·  TODDLZ</a:t>
+              <a:t>OGAREN  ·  SLEEPER  ·  nooer  ·  Toddles</a:t>
             </a:r>
             <a:endParaRPr lang="en-US" sz="800" dirty="0"/>
           </a:p>
@@ -8097,7 +8097,7 @@
                 <a:ea typeface="Malgun Gothic" pitchFamily="34" charset="-122"/>
                 <a:cs typeface="Malgun Gothic" pitchFamily="34" charset="-120"/>
               </a:rPr>
-              <a:t>OGAREN  ·  SLEEPER  ·  NOOER  ·  TODDLZ</a:t>
+              <a:t>OGAREN  ·  SLEEPER  ·  nooer  ·  Toddles</a:t>
             </a:r>
             <a:endParaRPr lang="en-US" sz="800" dirty="0"/>
           </a:p>
@@ -8740,7 +8740,7 @@
                 <a:ea typeface="Malgun Gothic" pitchFamily="34" charset="-122"/>
                 <a:cs typeface="Malgun Gothic" pitchFamily="34" charset="-120"/>
               </a:rPr>
-              <a:t>OGAREN  ·  SLEEPER  ·  NOOER  ·  TODDLZ</a:t>
+              <a:t>OGAREN  ·  SLEEPER  ·  nooer  ·  Toddles</a:t>
             </a:r>
             <a:endParaRPr lang="en-US" sz="800" dirty="0"/>
           </a:p>
@@ -9400,7 +9400,7 @@
                 <a:ea typeface="Malgun Gothic" pitchFamily="34" charset="-122"/>
                 <a:cs typeface="Malgun Gothic" pitchFamily="34" charset="-120"/>
               </a:rPr>
-              <a:t>OGAREN  ·  SLEEPER  ·  NOOER  ·  TODDLZ</a:t>
+              <a:t>OGAREN  ·  SLEEPER  ·  nooer  ·  Toddles</a:t>
             </a:r>
             <a:endParaRPr lang="en-US" sz="800" dirty="0"/>
           </a:p>
@@ -10043,7 +10043,7 @@
                 <a:ea typeface="Malgun Gothic" pitchFamily="34" charset="-122"/>
                 <a:cs typeface="Malgun Gothic" pitchFamily="34" charset="-120"/>
               </a:rPr>
-              <a:t>OGAREN  ·  SLEEPER  ·  NOOER  ·  TODDLZ</a:t>
+              <a:t>OGAREN  ·  SLEEPER  ·  nooer  ·  Toddles</a:t>
             </a:r>
             <a:endParaRPr lang="en-US" sz="800" dirty="0"/>
           </a:p>
@@ -10588,7 +10588,7 @@
                 <a:ea typeface="Malgun Gothic" pitchFamily="34" charset="-122"/>
                 <a:cs typeface="Malgun Gothic" pitchFamily="34" charset="-120"/>
               </a:rPr>
-              <a:t>OGAREN  ·  SLEEPER  ·  NOOER  ·  TODDLZ</a:t>
+              <a:t>OGAREN  ·  SLEEPER  ·  nooer  ·  Toddles</a:t>
             </a:r>
             <a:endParaRPr lang="en-US" sz="800" dirty="0"/>
           </a:p>
@@ -11472,7 +11472,7 @@
                 <a:ea typeface="Malgun Gothic" pitchFamily="34" charset="-122"/>
                 <a:cs typeface="Malgun Gothic" pitchFamily="34" charset="-120"/>
               </a:rPr>
-              <a:t>OGAREN  ·  SLEEPER  ·  NOOER  ·  TODDLZ</a:t>
+              <a:t>OGAREN  ·  SLEEPER  ·  nooer  ·  Toddles</a:t>
             </a:r>
             <a:endParaRPr lang="en-US" sz="800" dirty="0"/>
           </a:p>
@@ -12374,7 +12374,7 @@
                 <a:ea typeface="Malgun Gothic" pitchFamily="34" charset="-122"/>
                 <a:cs typeface="Malgun Gothic" pitchFamily="34" charset="-120"/>
               </a:rPr>
-              <a:t>OGAREN  ·  SLEEPER  ·  NOOER  ·  TODDLZ</a:t>
+              <a:t>OGAREN  ·  SLEEPER  ·  nooer  ·  Toddles</a:t>
             </a:r>
             <a:endParaRPr lang="en-US" sz="800" dirty="0"/>
           </a:p>
@@ -13983,7 +13983,7 @@
                 <a:ea typeface="Malgun Gothic" pitchFamily="34" charset="-122"/>
                 <a:cs typeface="Malgun Gothic" pitchFamily="34" charset="-120"/>
               </a:rPr>
-              <a:t>OGAREN  ·  SLEEPER  ·  NOOER  ·  TODDLZ</a:t>
+              <a:t>OGAREN  ·  SLEEPER  ·  nooer  ·  Toddles</a:t>
             </a:r>
             <a:endParaRPr lang="en-US" sz="800" dirty="0"/>
           </a:p>
@@ -14973,7 +14973,7 @@
                 <a:ea typeface="Malgun Gothic" pitchFamily="34" charset="-122"/>
                 <a:cs typeface="Malgun Gothic" pitchFamily="34" charset="-120"/>
               </a:rPr>
-              <a:t>OGAREN  ·  SLEEPER  ·  NOOER  ·  TODDLZ</a:t>
+              <a:t>OGAREN  ·  SLEEPER  ·  nooer  ·  Toddles</a:t>
             </a:r>
             <a:endParaRPr lang="en-US" sz="800" dirty="0"/>
           </a:p>
@@ -15963,7 +15963,7 @@
                 <a:ea typeface="Malgun Gothic" pitchFamily="34" charset="-122"/>
                 <a:cs typeface="Malgun Gothic" pitchFamily="34" charset="-120"/>
               </a:rPr>
-              <a:t>OGAREN  ·  SLEEPER  ·  NOOER  ·  TODDLZ</a:t>
+              <a:t>OGAREN  ·  SLEEPER  ·  nooer  ·  Toddles</a:t>
             </a:r>
             <a:endParaRPr lang="en-US" sz="800" dirty="0"/>
           </a:p>
@@ -17103,7 +17103,7 @@
                 <a:ea typeface="Malgun Gothic" pitchFamily="34" charset="-122"/>
                 <a:cs typeface="Malgun Gothic" pitchFamily="34" charset="-120"/>
               </a:rPr>
-              <a:t>OGAREN  ·  SLEEPER  ·  NOOER  ·  TODDLZ</a:t>
+              <a:t>OGAREN  ·  SLEEPER  ·  nooer  ·  Toddles</a:t>
             </a:r>
             <a:endParaRPr lang="en-US" sz="800" dirty="0"/>
           </a:p>
@@ -19199,7 +19199,7 @@
                 <a:ea typeface="Malgun Gothic" pitchFamily="34" charset="-122"/>
                 <a:cs typeface="Malgun Gothic" pitchFamily="34" charset="-120"/>
               </a:rPr>
-              <a:t>OGAREN  ·  SLEEPER  ·  NOOER  ·  TODDLZ</a:t>
+              <a:t>OGAREN  ·  SLEEPER  ·  nooer  ·  Toddles</a:t>
             </a:r>
             <a:endParaRPr lang="en-US" sz="800" dirty="0"/>
           </a:p>
@@ -20704,7 +20704,7 @@
                 <a:ea typeface="Malgun Gothic" pitchFamily="34" charset="-122"/>
                 <a:cs typeface="Malgun Gothic" pitchFamily="34" charset="-120"/>
               </a:rPr>
-              <a:t>OGAREN  ·  SLEEPER  ·  NOOER  ·  TODDLZ</a:t>
+              <a:t>OGAREN  ·  SLEEPER  ·  nooer  ·  Toddles</a:t>
             </a:r>
             <a:endParaRPr lang="en-US" sz="800" dirty="0"/>
           </a:p>
@@ -21682,7 +21682,7 @@
                 <a:ea typeface="Malgun Gothic" pitchFamily="34" charset="-122"/>
                 <a:cs typeface="Malgun Gothic" pitchFamily="34" charset="-120"/>
               </a:rPr>
-              <a:t>OGAREN  ·  SLEEPER  ·  NOOER  ·  TODDLZ</a:t>
+              <a:t>OGAREN  ·  SLEEPER  ·  nooer  ·  Toddles</a:t>
             </a:r>
             <a:endParaRPr lang="en-US" sz="800" dirty="0"/>
           </a:p>
@@ -22588,7 +22588,7 @@
                 <a:ea typeface="Malgun Gothic" pitchFamily="34" charset="-122"/>
                 <a:cs typeface="Malgun Gothic" pitchFamily="34" charset="-120"/>
               </a:rPr>
-              <a:t>OGAREN  ·  SLEEPER  ·  NOOER  ·  TODDLZ</a:t>
+              <a:t>OGAREN  ·  SLEEPER  ·  nooer  ·  Toddles</a:t>
             </a:r>
             <a:endParaRPr lang="en-US" sz="800" dirty="0"/>
           </a:p>
@@ -23689,7 +23689,7 @@
                 <a:ea typeface="Malgun Gothic" pitchFamily="34" charset="-122"/>
                 <a:cs typeface="Malgun Gothic" pitchFamily="34" charset="-120"/>
               </a:rPr>
-              <a:t>OGAREN  ·  SLEEPER  ·  NOOER  ·  TODDLZ</a:t>
+              <a:t>OGAREN  ·  SLEEPER  ·  nooer  ·  Toddles</a:t>
             </a:r>
             <a:endParaRPr lang="en-US" sz="800" dirty="0"/>
           </a:p>
@@ -24957,7 +24957,7 @@
                 <a:ea typeface="Malgun Gothic" pitchFamily="34" charset="-122"/>
                 <a:cs typeface="Malgun Gothic" pitchFamily="34" charset="-120"/>
               </a:rPr>
-              <a:t>OGAREN  ·  SLEEPER  ·  NOOER  ·  TODDLZ</a:t>
+              <a:t>OGAREN  ·  SLEEPER  ·  nooer  ·  Toddles</a:t>
             </a:r>
             <a:endParaRPr lang="en-US" sz="800" dirty="0"/>
           </a:p>
@@ -27271,7 +27271,7 @@
                 <a:ea typeface="Malgun Gothic" pitchFamily="34" charset="-122"/>
                 <a:cs typeface="Malgun Gothic" pitchFamily="34" charset="-120"/>
               </a:rPr>
-              <a:t>OGAREN  ·  SLEEPER  ·  NOOER  ·  TODDLZ</a:t>
+              <a:t>OGAREN  ·  SLEEPER  ·  nooer  ·  Toddles</a:t>
             </a:r>
             <a:endParaRPr lang="en-US" sz="800" dirty="0"/>
           </a:p>
@@ -28567,7 +28567,7 @@
                 <a:ea typeface="Malgun Gothic" pitchFamily="34" charset="-122"/>
                 <a:cs typeface="Malgun Gothic" pitchFamily="34" charset="-120"/>
               </a:rPr>
-              <a:t>OGAREN  ·  SLEEPER  ·  NOOER  ·  TODDLZ</a:t>
+              <a:t>OGAREN  ·  SLEEPER  ·  nooer  ·  Toddles</a:t>
             </a:r>
             <a:endParaRPr lang="en-US" sz="800" dirty="0"/>
           </a:p>
@@ -29748,7 +29748,7 @@
                 <a:ea typeface="Malgun Gothic" pitchFamily="34" charset="-122"/>
                 <a:cs typeface="Malgun Gothic" pitchFamily="34" charset="-120"/>
               </a:rPr>
-              <a:t>OGAREN  ·  SLEEPER  ·  NOOER  ·  TODDLZ</a:t>
+              <a:t>OGAREN  ·  SLEEPER  ·  nooer  ·  Toddles</a:t>
             </a:r>
             <a:endParaRPr lang="en-US" sz="800" dirty="0"/>
           </a:p>
@@ -31268,7 +31268,7 @@
                 <a:ea typeface="Malgun Gothic" pitchFamily="34" charset="-122"/>
                 <a:cs typeface="Malgun Gothic" pitchFamily="34" charset="-120"/>
               </a:rPr>
-              <a:t>OGAREN  ·  SLEEPER  ·  NOOER  ·  TODDLZ</a:t>
+              <a:t>OGAREN  ·  SLEEPER  ·  nooer  ·  Toddles</a:t>
             </a:r>
             <a:endParaRPr lang="en-US" sz="800" dirty="0"/>
           </a:p>
@@ -32905,7 +32905,7 @@
                 <a:ea typeface="Malgun Gothic" pitchFamily="34" charset="-122"/>
                 <a:cs typeface="Malgun Gothic" pitchFamily="34" charset="-120"/>
               </a:rPr>
-              <a:t>OGAREN  ·  SLEEPER  ·  NOOER  ·  TODDLZ</a:t>
+              <a:t>OGAREN  ·  SLEEPER  ·  nooer  ·  Toddles</a:t>
             </a:r>
             <a:endParaRPr lang="en-US" sz="800" dirty="0"/>
           </a:p>
@@ -34510,7 +34510,7 @@
                 <a:ea typeface="Malgun Gothic" pitchFamily="34" charset="-122"/>
                 <a:cs typeface="Malgun Gothic" pitchFamily="34" charset="-120"/>
               </a:rPr>
-              <a:t>OGAREN  ·  SLEEPER  ·  NOOER  ·  TODDLZ</a:t>
+              <a:t>OGAREN  ·  SLEEPER  ·  nooer  ·  Toddles</a:t>
             </a:r>
             <a:endParaRPr lang="en-US" sz="800" dirty="0"/>
           </a:p>
@@ -34757,7 +34757,7 @@
                 <a:ea typeface="Malgun Gothic" pitchFamily="34" charset="-122"/>
                 <a:cs typeface="Malgun Gothic" pitchFamily="34" charset="-120"/>
               </a:rPr>
-              <a:t>SLEEPER  ·  NOOER  ·  TODDLZ  ·  OGAREN</a:t>
+              <a:t>SLEEPER  ·  nooer  ·  Toddles  ·  OGAREN</a:t>
             </a:r>
             <a:endParaRPr lang="en-US" sz="1200" dirty="0"/>
           </a:p>
@@ -36478,7 +36478,7 @@
                 <a:ea typeface="Malgun Gothic" pitchFamily="34" charset="-122"/>
                 <a:cs typeface="Malgun Gothic" pitchFamily="34" charset="-120"/>
               </a:rPr>
-              <a:t>OGAREN  ·  SLEEPER  ·  NOOER  ·  TODDLZ</a:t>
+              <a:t>OGAREN  ·  SLEEPER  ·  nooer  ·  Toddles</a:t>
             </a:r>
             <a:endParaRPr lang="en-US" sz="800" dirty="0"/>
           </a:p>
@@ -37774,7 +37774,7 @@
                 <a:ea typeface="Malgun Gothic" pitchFamily="34" charset="-122"/>
                 <a:cs typeface="Malgun Gothic" pitchFamily="34" charset="-120"/>
               </a:rPr>
-              <a:t>OGAREN  ·  SLEEPER  ·  NOOER  ·  TODDLZ</a:t>
+              <a:t>OGAREN  ·  SLEEPER  ·  nooer  ·  Toddles</a:t>
             </a:r>
             <a:endParaRPr lang="en-US" sz="800" dirty="0"/>
           </a:p>
@@ -38691,7 +38691,7 @@
                 <a:ea typeface="Malgun Gothic" pitchFamily="34" charset="-122"/>
                 <a:cs typeface="Malgun Gothic" pitchFamily="34" charset="-120"/>
               </a:rPr>
-              <a:t>OGAREN  ·  SLEEPER  ·  NOOER  ·  TODDLZ</a:t>
+              <a:t>OGAREN  ·  SLEEPER  ·  nooer  ·  Toddles</a:t>
             </a:r>
             <a:endParaRPr lang="en-US" sz="800" dirty="0"/>
           </a:p>
@@ -39749,7 +39749,7 @@
                 <a:ea typeface="Malgun Gothic" pitchFamily="34" charset="-122"/>
                 <a:cs typeface="Malgun Gothic" pitchFamily="34" charset="-120"/>
               </a:rPr>
-              <a:t>OGAREN  ·  SLEEPER  ·  NOOER  ·  TODDLZ</a:t>
+              <a:t>OGAREN  ·  SLEEPER  ·  nooer  ·  Toddles</a:t>
             </a:r>
             <a:endParaRPr lang="en-US" sz="800" dirty="0"/>
           </a:p>
@@ -40694,7 +40694,7 @@
                 <a:ea typeface="Malgun Gothic" pitchFamily="34" charset="-122"/>
                 <a:cs typeface="Malgun Gothic" pitchFamily="34" charset="-120"/>
               </a:rPr>
-              <a:t>OGAREN  ·  SLEEPER  ·  NOOER  ·  TODDLZ</a:t>
+              <a:t>OGAREN  ·  SLEEPER  ·  nooer  ·  Toddles</a:t>
             </a:r>
             <a:endParaRPr lang="en-US" sz="800" dirty="0"/>
           </a:p>

</xml_diff>